<commit_message>
Deck: clarify RESULTS.md and benchmark run time claims, clear leftover speaker notes; re-render PDF
</commit_message>
<xml_diff>
--- a/Thapar_Institute_of_Engineering_and_Technology_Romantic_Shers_Submission.pptx
+++ b/Thapar_Institute_of_Engineering_and_Technology_Romantic_Shers_Submission.pptx
@@ -1883,7 +1883,7 @@
             </a:pPr>
             <a:r>
               <a:rPr lang="en-US"/>
-              <a:t>Closing slide. Add the Google Form URL and a contact email before sharing. Edition 2 organising team for reference: Language AI - Sourabh Tiwari, Gaurav, Sanjeeth Pothireddy, Gorang Maniar; PRISM - Binny Lakra, Prakhar Chandrakar, Vishu Kumar; Kick-off and mentors - Giridhar Jakki, Deepraj Prabhakar Patkar (Language AI), Srimanu Prasad Nagaraju, Ashish Kumar (Tech Strategy).</a:t>
+              <a:t/>
             </a:r>
             <a:endParaRPr/>
           </a:p>
@@ -13564,7 +13564,7 @@
                 <a:cs typeface="Calibri"/>
                 <a:sym typeface="Calibri"/>
               </a:rPr>
-              <a:t>all runs are logged in prism/eval/RESULTS.md, including the ones that failed (BM25 fusion dropped NDCG@10 from 0.235 to 0.228, 0.213 and 0.173).</a:t>
+              <a:t>every completed MTEB run is logged in prism/eval/RESULTS.md, including the ones that did not help, plus an offline BM25 fusion check (fusion dropped NDCG@10 from 0.235 to 0.228, 0.213 and 0.173).</a:t>
             </a:r>
           </a:p>
           <a:p>
@@ -17903,7 +17903,7 @@
                 <a:cs typeface="Calibri"/>
                 <a:sym typeface="Calibri"/>
               </a:rPr>
-              <a:t>AppsRetrieval: NDCG@10 0.514 | MRR@10 0.470 with SFR-Embedding-Code-400M_R + query cleanup, vs 0.056 | 0.048 for bge-small. Full run took 58 min.</a:t>
+              <a:t>AppsRetrieval: NDCG@10 0.514 | MRR@10 0.470 with SFR-Embedding-Code-400M_R + query cleanup, vs 0.056 | 0.048 for bge-small. A full run from scratch takes 58 min (the submitted run reused cached corpus embeddings).</a:t>
             </a:r>
           </a:p>
           <a:p>

</xml_diff>